<commit_message>
more docs, style code
</commit_message>
<xml_diff>
--- a/inst/ext/example_01.pptx
+++ b/inst/ext/example_01.pptx
@@ -2623,7 +2623,7 @@
                   <a:srgbClr val="00B0F0"/>
                 </a:solidFill>
               </a:rPr>
-              <a:t>{</a:t>
+              <a:t>@</a:t>
             </a:r>
             <a:r>
               <a:rPr lang="de-DE" dirty="0">
@@ -2631,7 +2631,7 @@
                   <a:srgbClr val="FF0000"/>
                 </a:solidFill>
               </a:rPr>
-              <a:t>@} </a:t>
+              <a:t> </a:t>
             </a:r>
             <a:r>
               <a:rPr lang="de-DE" dirty="0"/>
@@ -2646,7 +2646,7 @@
                   <a:srgbClr val="84CFEF"/>
                 </a:highlight>
               </a:rPr>
-              <a:t>{</a:t>
+              <a:t>@</a:t>
             </a:r>
             <a:r>
               <a:rPr lang="de-DE" dirty="0">
@@ -2654,7 +2654,7 @@
                   <a:srgbClr val="FF0000"/>
                 </a:solidFill>
               </a:rPr>
-              <a:t>@} </a:t>
+              <a:t> </a:t>
             </a:r>
             <a:r>
               <a:rPr lang="de-DE" dirty="0"/>
@@ -2662,12 +2662,9 @@
             </a:r>
             <a:r>
               <a:rPr lang="de-DE" sz="3600" dirty="0"/>
-              <a:t>{</a:t>
-            </a:r>
-            <a:r>
-              <a:rPr lang="de-DE" dirty="0"/>
-              <a:t>@}</a:t>
-            </a:r>
+              <a:t>@</a:t>
+            </a:r>
+            <a:endParaRPr lang="de-DE" dirty="0"/>
           </a:p>
           <a:p>
             <a:pPr marL="0" indent="0">
@@ -2679,7 +2676,7 @@
             </a:pPr>
             <a:r>
               <a:rPr lang="de-DE" dirty="0"/>
-              <a:t>xxx {@} xxx</a:t>
+              <a:t>xxx @ xxx</a:t>
             </a:r>
           </a:p>
           <a:p>
@@ -2703,11 +2700,11 @@
                   <a:srgbClr val="00FFFF"/>
                 </a:highlight>
               </a:rPr>
-              <a:t>{</a:t>
+              <a:t>@</a:t>
             </a:r>
             <a:r>
               <a:rPr lang="de-DE" dirty="0"/>
-              <a:t>@} xxx</a:t>
+              <a:t> xxx</a:t>
             </a:r>
             <a:endParaRPr lang="de-DE" dirty="0">
               <a:solidFill>
@@ -2737,7 +2734,7 @@
                   <a:srgbClr val="00B050"/>
                 </a:solidFill>
               </a:rPr>
-              <a:t>{</a:t>
+              <a:t>@</a:t>
             </a:r>
             <a:r>
               <a:rPr lang="de-DE" dirty="0">
@@ -2745,7 +2742,7 @@
                   <a:srgbClr val="00B050"/>
                 </a:solidFill>
               </a:rPr>
-              <a:t>@} xxx</a:t>
+              <a:t> xxx</a:t>
             </a:r>
           </a:p>
           <a:p>
@@ -2954,7 +2951,7 @@
                   <a:srgbClr val="00B0F0"/>
                 </a:solidFill>
               </a:rPr>
-              <a:t>{@}</a:t>
+              <a:t>@</a:t>
             </a:r>
           </a:p>
         </p:txBody>

</xml_diff>